<commit_message>
v1.0 with no LLM
</commit_message>
<xml_diff>
--- a/PPT_Framework/templates/template.pptx
+++ b/PPT_Framework/templates/template.pptx
@@ -12696,6 +12696,43 @@
               <a:cs typeface="微软雅黑" panose="020B0503020204020204" pitchFamily="34" charset="-122"/>
               <a:sym typeface="+mn-lt"/>
             </a:endParaRPr>
+          </a:p>
+        </p:txBody>
+      </p:sp>
+      <p:sp>
+        <p:nvSpPr>
+          <p:cNvPr id="2" name="文本框 1"/>
+          <p:cNvSpPr txBox="1"/>
+          <p:nvPr/>
+        </p:nvSpPr>
+        <p:spPr>
+          <a:xfrm>
+            <a:off x="4998720" y="3074670"/>
+            <a:ext cx="2194560" cy="708660"/>
+          </a:xfrm>
+          <a:prstGeom prst="rect">
+            <a:avLst/>
+          </a:prstGeom>
+          <a:noFill/>
+        </p:spPr>
+        <p:txBody>
+          <a:bodyPr wrap="square" rtlCol="0">
+            <a:noAutofit/>
+          </a:bodyPr>
+          <a:p>
+            <a:r>
+              <a:rPr lang="en-US" altLang="zh-CN" sz="3600"/>
+              <a:t>{{</a:t>
+            </a:r>
+            <a:r>
+              <a:rPr lang="zh-CN" altLang="en-US" sz="3600"/>
+              <a:t>定位页</a:t>
+            </a:r>
+            <a:r>
+              <a:rPr lang="en-US" altLang="zh-CN" sz="3600"/>
+              <a:t>}}</a:t>
+            </a:r>
+            <a:endParaRPr lang="en-US" altLang="zh-CN" sz="3600"/>
           </a:p>
         </p:txBody>
       </p:sp>
@@ -14475,6 +14512,43 @@
               <a:cs typeface="微软雅黑" panose="020B0503020204020204" pitchFamily="34" charset="-122"/>
               <a:sym typeface="+mn-lt"/>
             </a:endParaRPr>
+          </a:p>
+        </p:txBody>
+      </p:sp>
+      <p:sp>
+        <p:nvSpPr>
+          <p:cNvPr id="2" name="文本框 1"/>
+          <p:cNvSpPr txBox="1"/>
+          <p:nvPr/>
+        </p:nvSpPr>
+        <p:spPr>
+          <a:xfrm>
+            <a:off x="4998720" y="3074670"/>
+            <a:ext cx="2194560" cy="708660"/>
+          </a:xfrm>
+          <a:prstGeom prst="rect">
+            <a:avLst/>
+          </a:prstGeom>
+          <a:noFill/>
+        </p:spPr>
+        <p:txBody>
+          <a:bodyPr wrap="square" rtlCol="0">
+            <a:noAutofit/>
+          </a:bodyPr>
+          <a:p>
+            <a:r>
+              <a:rPr lang="en-US" altLang="zh-CN" sz="3600"/>
+              <a:t>{{</a:t>
+            </a:r>
+            <a:r>
+              <a:rPr lang="zh-CN" altLang="en-US" sz="3600"/>
+              <a:t>定位页</a:t>
+            </a:r>
+            <a:r>
+              <a:rPr lang="en-US" altLang="zh-CN" sz="3600"/>
+              <a:t>}}</a:t>
+            </a:r>
+            <a:endParaRPr lang="en-US" altLang="zh-CN" sz="3600"/>
           </a:p>
         </p:txBody>
       </p:sp>

</xml_diff>